<commit_message>
the world of AI. In focus section color changed
</commit_message>
<xml_diff>
--- a/deliverables/BELLORA_PULSE_Project_Overview.pptx
+++ b/deliverables/BELLORA_PULSE_Project_Overview.pptx
@@ -4610,7 +4610,7 @@
             <a:avLst/>
           </a:prstGeom>
           <a:solidFill>
-            <a:srgbClr val="0B1220"/>
+            <a:schemeClr val="bg1"/>
           </a:solidFill>
           <a:ln>
             <a:noFill/>
@@ -4636,51 +4636,6 @@
           <a:p>
             <a:pPr algn="ctr"/>
             <a:endParaRPr/>
-          </a:p>
-        </p:txBody>
-      </p:sp>
-      <p:sp>
-        <p:nvSpPr>
-          <p:cNvPr id="3" name="TextBox 2"/>
-          <p:cNvSpPr txBox="1"/>
-          <p:nvPr/>
-        </p:nvSpPr>
-        <p:spPr>
-          <a:xfrm>
-            <a:off x="533400" y="254000"/>
-            <a:ext cx="2032000" cy="228600"/>
-          </a:xfrm>
-          <a:prstGeom prst="rect">
-            <a:avLst/>
-          </a:prstGeom>
-          <a:noFill/>
-        </p:spPr>
-        <p:txBody>
-          <a:bodyPr wrap="square" lIns="0" tIns="0" rIns="0" bIns="0" anchor="t">
-            <a:normAutofit/>
-          </a:bodyPr>
-          <a:lstStyle/>
-          <a:p>
-            <a:pPr algn="l">
-              <a:lnSpc>
-                <a:spcPts val="1488"/>
-              </a:lnSpc>
-              <a:spcBef>
-                <a:spcPts val="0"/>
-              </a:spcBef>
-              <a:spcAft>
-                <a:spcPts val="0"/>
-              </a:spcAft>
-              <a:defRPr sz="1200" b="1">
-                <a:solidFill>
-                  <a:srgbClr val="75AAFF"/>
-                </a:solidFill>
-                <a:latin typeface="Segoe UI Semibold"/>
-              </a:defRPr>
-            </a:pPr>
-            <a:r>
-              <a:t>BELLORA.PULSE</a:t>
-            </a:r>
           </a:p>
         </p:txBody>
       </p:sp>
@@ -4851,52 +4806,11 @@
           <a:lstStyle/>
           <a:p>
             <a:pPr algn="ctr"/>
-            <a:endParaRPr/>
-          </a:p>
-        </p:txBody>
-      </p:sp>
-      <p:sp>
-        <p:nvSpPr>
-          <p:cNvPr id="9" name="TextBox 8"/>
-          <p:cNvSpPr txBox="1"/>
-          <p:nvPr/>
-        </p:nvSpPr>
-        <p:spPr>
-          <a:xfrm>
-            <a:off x="660400" y="1219200"/>
-            <a:ext cx="2857500" cy="228600"/>
-          </a:xfrm>
-          <a:prstGeom prst="rect">
-            <a:avLst/>
-          </a:prstGeom>
-          <a:noFill/>
-        </p:spPr>
-        <p:txBody>
-          <a:bodyPr wrap="square" lIns="0" tIns="0" rIns="0" bIns="0" anchor="t">
-            <a:normAutofit/>
-          </a:bodyPr>
-          <a:lstStyle/>
-          <a:p>
-            <a:pPr algn="l">
-              <a:lnSpc>
-                <a:spcPts val="1364"/>
-              </a:lnSpc>
-              <a:spcBef>
-                <a:spcPts val="0"/>
-              </a:spcBef>
-              <a:spcAft>
-                <a:spcPts val="0"/>
-              </a:spcAft>
-              <a:defRPr sz="1100" b="1">
-                <a:solidFill>
-                  <a:srgbClr val="75AAFF"/>
-                </a:solidFill>
-                <a:latin typeface="Segoe UI Semibold"/>
-              </a:defRPr>
-            </a:pPr>
-            <a:r>
-              <a:t>DISCOVER / LEARN / EXPLORE</a:t>
-            </a:r>
+            <a:r>
+              <a:rPr lang="en-US" dirty="0"/>
+              <a:t> </a:t>
+            </a:r>
+            <a:endParaRPr dirty="0"/>
           </a:p>
         </p:txBody>
       </p:sp>
@@ -4940,6 +4854,13 @@
               </a:defRPr>
             </a:pPr>
             <a:r>
+              <a:rPr dirty="0">
+                <a:solidFill>
+                  <a:schemeClr val="tx2">
+                    <a:lumMod val="75000"/>
+                  </a:schemeClr>
+                </a:solidFill>
+              </a:rPr>
               <a:t>BELLORA.PULSE</a:t>
             </a:r>
           </a:p>
@@ -4985,6 +4906,13 @@
               </a:defRPr>
             </a:pPr>
             <a:r>
+              <a:rPr dirty="0">
+                <a:solidFill>
+                  <a:schemeClr val="tx2">
+                    <a:lumMod val="75000"/>
+                  </a:schemeClr>
+                </a:solidFill>
+              </a:rPr>
               <a:t>Your starting point</a:t>
             </a:r>
           </a:p>
@@ -5007,6 +4935,13 @@
               </a:defRPr>
             </a:pPr>
             <a:r>
+              <a:rPr dirty="0">
+                <a:solidFill>
+                  <a:schemeClr val="tx2">
+                    <a:lumMod val="75000"/>
+                  </a:schemeClr>
+                </a:solidFill>
+              </a:rPr>
               <a:t>for the world of AI.</a:t>
             </a:r>
           </a:p>
@@ -5052,6 +4987,13 @@
               </a:defRPr>
             </a:pPr>
             <a:r>
+              <a:rPr dirty="0">
+                <a:solidFill>
+                  <a:schemeClr val="tx2">
+                    <a:lumMod val="75000"/>
+                  </a:schemeClr>
+                </a:solidFill>
+              </a:rPr>
               <a:t>News, tools, podcasts and trusted AI voices.</a:t>
             </a:r>
           </a:p>

</xml_diff>